<commit_message>
chore: Ahmed Ramadan is Ahmed Saleh
Renamed on the title and thank-you slides, in the speaker headers and the part
ownership, and in the demo runbook, so the generated script follows.

Also in three places outside the deck, because the name identifies a person
rather than the presentation. `lib/data/team.ts` is the one that mattered: the
About page renders it, so leaving it would have contradicted the deck on screen
during the demo. Initials go AR -> AS with it; the matriculation number is
unchanged, and `AS` collides with nothing (AE, ME, AO).

The `AR` writer-slot code in the human-baseline assignment is documentation
only - it appears in no filename and no JSON key - so renaming the slot beside
the writer is safe. Alphabetical position by surname is unchanged, so the
writer-ordering note still holds.
</commit_message>
<xml_diff>
--- a/presentation/AI-Storytelling-Final-Talk.pptx
+++ b/presentation/AI-Storytelling-Final-Talk.pptx
@@ -1148,7 +1148,7 @@
           <a:lstStyle/>
           <a:p>
             <a:r>
-              <a:t>SPEAKER 4 - Ramadan   [0:05]   running total 5:21   ~15 words</a:t>
+              <a:t>SPEAKER 4 - Saleh   [0:05]   running total 5:21   ~15 words</a:t>
             </a:r>
           </a:p>
           <a:p/>
@@ -1230,7 +1230,7 @@
           <a:lstStyle/>
           <a:p>
             <a:r>
-              <a:t>SPEAKER 4 - Ramadan   [0:38]   running total 5:59   ~105 words</a:t>
+              <a:t>SPEAKER 4 - Saleh   [0:38]   running total 5:59   ~105 words</a:t>
             </a:r>
           </a:p>
           <a:p/>
@@ -1360,7 +1360,7 @@
           <a:lstStyle/>
           <a:p>
             <a:r>
-              <a:t>SPEAKER 4 - Ramadan   [0:40]   running total 6:39   ~105 words</a:t>
+              <a:t>SPEAKER 4 - Saleh   [0:40]   running total 6:39   ~105 words</a:t>
             </a:r>
           </a:p>
           <a:p/>
@@ -1490,7 +1490,7 @@
           <a:lstStyle/>
           <a:p>
             <a:r>
-              <a:t>SPEAKER 4 - Ramadan   [0:21]   running total 7:00   ~50 words   &gt;&gt;&gt; DEMO</a:t>
+              <a:t>SPEAKER 4 - Saleh   [0:21]   running total 7:00   ~50 words   &gt;&gt;&gt; DEMO</a:t>
             </a:r>
           </a:p>
           <a:p/>
@@ -5997,7 +5997,7 @@
                 </a:solidFill>
                 <a:latin typeface="Calibri"/>
               </a:rPr>
-              <a:t>Mahmoud Elsamadony  ·  Ahmed Okasha  ·  Ahmed Elsaadani  ·  Ahmed Ramadan</a:t>
+              <a:t>Mahmoud Elsamadony  ·  Ahmed Okasha  ·  Ahmed Elsaadani  ·  Ahmed Saleh</a:t>
             </a:r>
           </a:p>
           <a:p>
@@ -8962,7 +8962,7 @@
                 </a:solidFill>
                 <a:latin typeface="Calibri"/>
               </a:rPr>
-              <a:t>Ramadan</a:t>
+              <a:t>Saleh</a:t>
             </a:r>
           </a:p>
         </p:txBody>
@@ -14065,7 +14065,7 @@
                 </a:solidFill>
                 <a:latin typeface="Calibri"/>
               </a:rPr>
-              <a:t>Ramadan</a:t>
+              <a:t>Saleh</a:t>
             </a:r>
           </a:p>
         </p:txBody>
@@ -14696,7 +14696,7 @@
                 </a:solidFill>
                 <a:latin typeface="Calibri"/>
               </a:rPr>
-              <a:t>Mahmoud Elsamadony  ·  Ahmed Okasha  ·  Ahmed Elsaadani  ·  Ahmed Ramadan</a:t>
+              <a:t>Mahmoud Elsamadony  ·  Ahmed Okasha  ·  Ahmed Elsaadani  ·  Ahmed Saleh</a:t>
             </a:r>
           </a:p>
           <a:p>

</xml_diff>

<commit_message>
feat(presentation): slide 17 is the tool surface and nothing else
Dropped the three-layer applicability/select/validate strip and the
"specified, not wired" panel. The slide is now the surface itself: seven chart
tools with their form enums, the three read tools with what each returns, and
the one line that explains why the read tools are what make it an agent rather
than a classifier - blind form-picking from a prompt string versus looking at
the table and deriving that two measures differ by 100x.

The status survives as a single line under the tables rather than a panel:
defined in CHART_CONTRACT.md, pinned by the generated chart-schema.json, and
today the selector makes one structured call with the tool loop as the next
step. It is one clause, not a box, and the notes carry the answer if anyone
asks directly.

Talk is back to exactly 7:00 by word count.
</commit_message>
<xml_diff>
--- a/presentation/AI-Storytelling-Final-Talk.pptx
+++ b/presentation/AI-Storytelling-Final-Talk.pptx
@@ -1360,67 +1360,81 @@
           <a:lstStyle/>
           <a:p>
             <a:r>
-              <a:t>SPEAKER 4 - Saleh   [0:40]   running total 6:39   ~105 words</a:t>
+              <a:t>SPEAKER 4 - Saleh   [0:40]   running total 6:39   ~100 words</a:t>
             </a:r>
           </a:p>
           <a:p/>
           <a:p>
             <a:r>
-              <a:t>How the model picks the figures, because people ask.</a:t>
+              <a:t>How the model actually decides which figures to draw.</a:t>
             </a:r>
           </a:p>
           <a:p/>
           <a:p>
             <a:r>
-              <a:t>Three steps. Which forms can this table carry - computed from column types, so</a:t>
-            </a:r>
-          </a:p>
-          <a:p>
-            <a:r>
-              <a:t>it cannot propose a map for a table with no geography. Which are worth showing -</a:t>
-            </a:r>
-          </a:p>
-          <a:p>
-            <a:r>
-              <a:t>the model. Is the result honest - computed again.</a:t>
+              <a:t>Seventeen flat chart types is past what a local model picks reliably. So the</a:t>
+            </a:r>
+          </a:p>
+          <a:p>
+            <a:r>
+              <a:t>contract groups them into seven tools by the reader's job - trend over time,</a:t>
+            </a:r>
+          </a:p>
+          <a:p>
+            <a:r>
+              <a:t>magnitude, change, relationship, geographic, distribution, headline - and puts</a:t>
+            </a:r>
+          </a:p>
+          <a:p>
+            <a:r>
+              <a:t>the geometry in an enum inside each. That is a two-level decision, and it is one</a:t>
+            </a:r>
+          </a:p>
+          <a:p>
+            <a:r>
+              <a:t>a local model makes well.</a:t>
             </a:r>
           </a:p>
           <a:p/>
           <a:p>
             <a:r>
-              <a:t>The interesting part is the shape of the decision. Instead of seventeen flat</a:t>
-            </a:r>
-          </a:p>
-          <a:p>
-            <a:r>
-              <a:t>chart types, the contract groups them into seven tools by the reader's job, with</a:t>
-            </a:r>
-          </a:p>
-          <a:p>
-            <a:r>
-              <a:t>the geometry as an enum inside each. A two-level choice is what a local model</a:t>
-            </a:r>
-          </a:p>
-          <a:p>
-            <a:r>
-              <a:t>does reliably.</a:t>
+              <a:t>The three read tools on the right are what make this an agent rather than a</a:t>
+            </a:r>
+          </a:p>
+          <a:p>
+            <a:r>
+              <a:t>classifier. Without them the model picks a form blind from a prompt string. With</a:t>
+            </a:r>
+          </a:p>
+          <a:p>
+            <a:r>
+              <a:t>them it can look at the table first, find that two measures differ by a hundred</a:t>
+            </a:r>
+          </a:p>
+          <a:p>
+            <a:r>
+              <a:t>times, and derive that it needs an indexed transform.</a:t>
             </a:r>
           </a:p>
           <a:p/>
           <a:p>
             <a:r>
-              <a:t>That surface is MCP-shaped and specified - a design, not a running server.</a:t>
-            </a:r>
-          </a:p>
-          <a:p/>
-          <a:p>
-            <a:r>
-              <a:t>DELIVERY: say "specified, not wired" out loud. Someone will ask to see the</a:t>
-            </a:r>
-          </a:p>
-          <a:p>
-            <a:r>
-              <a:t>server.</a:t>
+              <a:t>DELIVERY: name the seven tools as a group, do not read them one by one. Spend</a:t>
+            </a:r>
+          </a:p>
+          <a:p>
+            <a:r>
+              <a:t>the time on the read tools - that is the interesting half. If asked whether the</a:t>
+            </a:r>
+          </a:p>
+          <a:p>
+            <a:r>
+              <a:t>MCP server is running: it is not, the selector makes one structured call today</a:t>
+            </a:r>
+          </a:p>
+          <a:p>
+            <a:r>
+              <a:t>and the tool loop is the next step.</a:t>
             </a:r>
           </a:p>
         </p:txBody>
@@ -9393,7 +9407,7 @@
                 </a:solidFill>
                 <a:latin typeface="Arial"/>
               </a:rPr>
-              <a:t>HOW THE MODEL PICKS THE CHARTS</a:t>
+              <a:t>THE TOOL SURFACE</a:t>
             </a:r>
           </a:p>
         </p:txBody>
@@ -9432,7 +9446,7 @@
                 </a:solidFill>
                 <a:latin typeface="Arial"/>
               </a:rPr>
-              <a:t>A tool surface, so the decision is the model's and the rules are not</a:t>
+              <a:t>Seventeen flat chart types is past what a local model picks. Seven tools plus an enum is not.</a:t>
             </a:r>
           </a:p>
         </p:txBody>
@@ -9483,14 +9497,53 @@
       </p:sp>
       <p:sp>
         <p:nvSpPr>
-          <p:cNvPr id="5" name="Rectangle 4"/>
+          <p:cNvPr id="5" name="TextBox 4"/>
+          <p:cNvSpPr txBox="1"/>
+          <p:nvPr/>
+        </p:nvSpPr>
+        <p:spPr>
+          <a:xfrm>
+            <a:off x="685800" y="2395728"/>
+            <a:ext cx="5760720" cy="274320"/>
+          </a:xfrm>
+          <a:prstGeom prst="rect">
+            <a:avLst/>
+          </a:prstGeom>
+          <a:noFill/>
+        </p:spPr>
+        <p:txBody>
+          <a:bodyPr wrap="square" anchor="t" lIns="0" rIns="0" tIns="0" bIns="0">
+            <a:spAutoFit/>
+          </a:bodyPr>
+          <a:lstStyle/>
+          <a:p>
+            <a:pPr algn="l">
+              <a:lnSpc>
+                <a:spcPct val="100000"/>
+              </a:lnSpc>
+            </a:pPr>
+            <a:r>
+              <a:rPr sz="1000" b="1">
+                <a:solidFill>
+                  <a:srgbClr val="526173"/>
+                </a:solidFill>
+                <a:latin typeface="Arial"/>
+              </a:rPr>
+              <a:t>CHART TOOLS (7)  —  each returns a ChartPayload</a:t>
+            </a:r>
+          </a:p>
+        </p:txBody>
+      </p:sp>
+      <p:sp>
+        <p:nvSpPr>
+          <p:cNvPr id="6" name="Rectangle 5"/>
           <p:cNvSpPr/>
           <p:nvPr/>
         </p:nvSpPr>
         <p:spPr>
           <a:xfrm>
-            <a:off x="685800" y="2103120"/>
-            <a:ext cx="3401568" cy="1170432"/>
+            <a:off x="685800" y="2706624"/>
+            <a:ext cx="5760720" cy="384048"/>
           </a:xfrm>
           <a:prstGeom prst="rect">
             <a:avLst/>
@@ -9527,14 +9580,770 @@
       </p:sp>
       <p:sp>
         <p:nvSpPr>
-          <p:cNvPr id="6" name="Rectangle 5"/>
+          <p:cNvPr id="7" name="TextBox 6"/>
+          <p:cNvSpPr txBox="1"/>
+          <p:nvPr/>
+        </p:nvSpPr>
+        <p:spPr>
+          <a:xfrm>
+            <a:off x="868680" y="2743200"/>
+            <a:ext cx="2514600" cy="274320"/>
+          </a:xfrm>
+          <a:prstGeom prst="rect">
+            <a:avLst/>
+          </a:prstGeom>
+          <a:noFill/>
+        </p:spPr>
+        <p:txBody>
+          <a:bodyPr wrap="square" anchor="t" lIns="0" rIns="0" tIns="0" bIns="0">
+            <a:spAutoFit/>
+          </a:bodyPr>
+          <a:lstStyle/>
+          <a:p>
+            <a:pPr algn="l">
+              <a:lnSpc>
+                <a:spcPct val="100000"/>
+              </a:lnSpc>
+            </a:pPr>
+            <a:r>
+              <a:rPr sz="1200" b="1">
+                <a:solidFill>
+                  <a:srgbClr val="0E8F86"/>
+                </a:solidFill>
+                <a:latin typeface="Calibri"/>
+              </a:rPr>
+              <a:t>plot_trend_over_time</a:t>
+            </a:r>
+          </a:p>
+        </p:txBody>
+      </p:sp>
+      <p:sp>
+        <p:nvSpPr>
+          <p:cNvPr id="8" name="TextBox 7"/>
+          <p:cNvSpPr txBox="1"/>
+          <p:nvPr/>
+        </p:nvSpPr>
+        <p:spPr>
+          <a:xfrm>
+            <a:off x="3520440" y="2752344"/>
+            <a:ext cx="2788920" cy="274320"/>
+          </a:xfrm>
+          <a:prstGeom prst="rect">
+            <a:avLst/>
+          </a:prstGeom>
+          <a:noFill/>
+        </p:spPr>
+        <p:txBody>
+          <a:bodyPr wrap="square" anchor="t" lIns="0" rIns="0" tIns="0" bIns="0">
+            <a:spAutoFit/>
+          </a:bodyPr>
+          <a:lstStyle/>
+          <a:p>
+            <a:pPr algn="l">
+              <a:lnSpc>
+                <a:spcPct val="100000"/>
+              </a:lnSpc>
+            </a:pPr>
+            <a:r>
+              <a:rPr sz="1100" b="0">
+                <a:solidFill>
+                  <a:srgbClr val="0F172A"/>
+                </a:solidFill>
+                <a:latin typeface="Calibri"/>
+              </a:rPr>
+              <a:t>line, area  (+ stack, indexed, emphasis)</a:t>
+            </a:r>
+          </a:p>
+        </p:txBody>
+      </p:sp>
+      <p:sp>
+        <p:nvSpPr>
+          <p:cNvPr id="9" name="TextBox 8"/>
+          <p:cNvSpPr txBox="1"/>
+          <p:nvPr/>
+        </p:nvSpPr>
+        <p:spPr>
+          <a:xfrm>
+            <a:off x="868680" y="3154680"/>
+            <a:ext cx="2514600" cy="274320"/>
+          </a:xfrm>
+          <a:prstGeom prst="rect">
+            <a:avLst/>
+          </a:prstGeom>
+          <a:noFill/>
+        </p:spPr>
+        <p:txBody>
+          <a:bodyPr wrap="square" anchor="t" lIns="0" rIns="0" tIns="0" bIns="0">
+            <a:spAutoFit/>
+          </a:bodyPr>
+          <a:lstStyle/>
+          <a:p>
+            <a:pPr algn="l">
+              <a:lnSpc>
+                <a:spcPct val="100000"/>
+              </a:lnSpc>
+            </a:pPr>
+            <a:r>
+              <a:rPr sz="1200" b="1">
+                <a:solidFill>
+                  <a:srgbClr val="0E8F86"/>
+                </a:solidFill>
+                <a:latin typeface="Calibri"/>
+              </a:rPr>
+              <a:t>plot_magnitude</a:t>
+            </a:r>
+          </a:p>
+        </p:txBody>
+      </p:sp>
+      <p:sp>
+        <p:nvSpPr>
+          <p:cNvPr id="10" name="TextBox 9"/>
+          <p:cNvSpPr txBox="1"/>
+          <p:nvPr/>
+        </p:nvSpPr>
+        <p:spPr>
+          <a:xfrm>
+            <a:off x="3520440" y="3163824"/>
+            <a:ext cx="2788920" cy="274320"/>
+          </a:xfrm>
+          <a:prstGeom prst="rect">
+            <a:avLst/>
+          </a:prstGeom>
+          <a:noFill/>
+        </p:spPr>
+        <p:txBody>
+          <a:bodyPr wrap="square" anchor="t" lIns="0" rIns="0" tIns="0" bIns="0">
+            <a:spAutoFit/>
+          </a:bodyPr>
+          <a:lstStyle/>
+          <a:p>
+            <a:pPr algn="l">
+              <a:lnSpc>
+                <a:spcPct val="100000"/>
+              </a:lnSpc>
+            </a:pPr>
+            <a:r>
+              <a:rPr sz="1100" b="0">
+                <a:solidFill>
+                  <a:srgbClr val="0F172A"/>
+                </a:solidFill>
+                <a:latin typeface="Calibri"/>
+              </a:rPr>
+              <a:t>bar, lollipop, heatmap</a:t>
+            </a:r>
+          </a:p>
+        </p:txBody>
+      </p:sp>
+      <p:sp>
+        <p:nvSpPr>
+          <p:cNvPr id="11" name="Rectangle 10"/>
           <p:cNvSpPr/>
           <p:nvPr/>
         </p:nvSpPr>
         <p:spPr>
           <a:xfrm>
-            <a:off x="685800" y="2103120"/>
-            <a:ext cx="3401568" cy="50800"/>
+            <a:off x="685800" y="3529584"/>
+            <a:ext cx="5760720" cy="384048"/>
+          </a:xfrm>
+          <a:prstGeom prst="rect">
+            <a:avLst/>
+          </a:prstGeom>
+          <a:solidFill>
+            <a:srgbClr val="EEF4F8"/>
+          </a:solidFill>
+          <a:ln>
+            <a:noFill/>
+          </a:ln>
+          <a:effectLst/>
+        </p:spPr>
+        <p:style>
+          <a:lnRef idx="1">
+            <a:schemeClr val="accent1"/>
+          </a:lnRef>
+          <a:fillRef idx="3">
+            <a:schemeClr val="accent1"/>
+          </a:fillRef>
+          <a:effectRef idx="2">
+            <a:schemeClr val="accent1"/>
+          </a:effectRef>
+          <a:fontRef idx="minor">
+            <a:schemeClr val="lt1"/>
+          </a:fontRef>
+        </p:style>
+        <p:txBody>
+          <a:bodyPr rtlCol="0" anchor="ctr"/>
+          <a:lstStyle/>
+          <a:p>
+            <a:pPr algn="ctr"/>
+          </a:p>
+        </p:txBody>
+      </p:sp>
+      <p:sp>
+        <p:nvSpPr>
+          <p:cNvPr id="12" name="TextBox 11"/>
+          <p:cNvSpPr txBox="1"/>
+          <p:nvPr/>
+        </p:nvSpPr>
+        <p:spPr>
+          <a:xfrm>
+            <a:off x="868680" y="3566160"/>
+            <a:ext cx="2514600" cy="274320"/>
+          </a:xfrm>
+          <a:prstGeom prst="rect">
+            <a:avLst/>
+          </a:prstGeom>
+          <a:noFill/>
+        </p:spPr>
+        <p:txBody>
+          <a:bodyPr wrap="square" anchor="t" lIns="0" rIns="0" tIns="0" bIns="0">
+            <a:spAutoFit/>
+          </a:bodyPr>
+          <a:lstStyle/>
+          <a:p>
+            <a:pPr algn="l">
+              <a:lnSpc>
+                <a:spcPct val="100000"/>
+              </a:lnSpc>
+            </a:pPr>
+            <a:r>
+              <a:rPr sz="1200" b="1">
+                <a:solidFill>
+                  <a:srgbClr val="0E8F86"/>
+                </a:solidFill>
+                <a:latin typeface="Calibri"/>
+              </a:rPr>
+              <a:t>plot_change</a:t>
+            </a:r>
+          </a:p>
+        </p:txBody>
+      </p:sp>
+      <p:sp>
+        <p:nvSpPr>
+          <p:cNvPr id="13" name="TextBox 12"/>
+          <p:cNvSpPr txBox="1"/>
+          <p:nvPr/>
+        </p:nvSpPr>
+        <p:spPr>
+          <a:xfrm>
+            <a:off x="3520440" y="3575303"/>
+            <a:ext cx="2788920" cy="274320"/>
+          </a:xfrm>
+          <a:prstGeom prst="rect">
+            <a:avLst/>
+          </a:prstGeom>
+          <a:noFill/>
+        </p:spPr>
+        <p:txBody>
+          <a:bodyPr wrap="square" anchor="t" lIns="0" rIns="0" tIns="0" bIns="0">
+            <a:spAutoFit/>
+          </a:bodyPr>
+          <a:lstStyle/>
+          <a:p>
+            <a:pPr algn="l">
+              <a:lnSpc>
+                <a:spcPct val="100000"/>
+              </a:lnSpc>
+            </a:pPr>
+            <a:r>
+              <a:rPr sz="1100" b="0">
+                <a:solidFill>
+                  <a:srgbClr val="0F172A"/>
+                </a:solidFill>
+                <a:latin typeface="Calibri"/>
+              </a:rPr>
+              <a:t>dumbbell, slope, bump</a:t>
+            </a:r>
+          </a:p>
+        </p:txBody>
+      </p:sp>
+      <p:sp>
+        <p:nvSpPr>
+          <p:cNvPr id="14" name="TextBox 13"/>
+          <p:cNvSpPr txBox="1"/>
+          <p:nvPr/>
+        </p:nvSpPr>
+        <p:spPr>
+          <a:xfrm>
+            <a:off x="868680" y="3977639"/>
+            <a:ext cx="2514600" cy="274320"/>
+          </a:xfrm>
+          <a:prstGeom prst="rect">
+            <a:avLst/>
+          </a:prstGeom>
+          <a:noFill/>
+        </p:spPr>
+        <p:txBody>
+          <a:bodyPr wrap="square" anchor="t" lIns="0" rIns="0" tIns="0" bIns="0">
+            <a:spAutoFit/>
+          </a:bodyPr>
+          <a:lstStyle/>
+          <a:p>
+            <a:pPr algn="l">
+              <a:lnSpc>
+                <a:spcPct val="100000"/>
+              </a:lnSpc>
+            </a:pPr>
+            <a:r>
+              <a:rPr sz="1200" b="1">
+                <a:solidFill>
+                  <a:srgbClr val="0E8F86"/>
+                </a:solidFill>
+                <a:latin typeface="Calibri"/>
+              </a:rPr>
+              <a:t>plot_relationship</a:t>
+            </a:r>
+          </a:p>
+        </p:txBody>
+      </p:sp>
+      <p:sp>
+        <p:nvSpPr>
+          <p:cNvPr id="15" name="TextBox 14"/>
+          <p:cNvSpPr txBox="1"/>
+          <p:nvPr/>
+        </p:nvSpPr>
+        <p:spPr>
+          <a:xfrm>
+            <a:off x="3520440" y="3986783"/>
+            <a:ext cx="2788920" cy="274320"/>
+          </a:xfrm>
+          <a:prstGeom prst="rect">
+            <a:avLst/>
+          </a:prstGeom>
+          <a:noFill/>
+        </p:spPr>
+        <p:txBody>
+          <a:bodyPr wrap="square" anchor="t" lIns="0" rIns="0" tIns="0" bIns="0">
+            <a:spAutoFit/>
+          </a:bodyPr>
+          <a:lstStyle/>
+          <a:p>
+            <a:pPr algn="l">
+              <a:lnSpc>
+                <a:spcPct val="100000"/>
+              </a:lnSpc>
+            </a:pPr>
+            <a:r>
+              <a:rPr sz="1100" b="0">
+                <a:solidFill>
+                  <a:srgbClr val="0F172A"/>
+                </a:solidFill>
+                <a:latin typeface="Calibri"/>
+              </a:rPr>
+              <a:t>scatter, connectedScatter, parallelCoordinates</a:t>
+            </a:r>
+          </a:p>
+        </p:txBody>
+      </p:sp>
+      <p:sp>
+        <p:nvSpPr>
+          <p:cNvPr id="16" name="Rectangle 15"/>
+          <p:cNvSpPr/>
+          <p:nvPr/>
+        </p:nvSpPr>
+        <p:spPr>
+          <a:xfrm>
+            <a:off x="685800" y="4352544"/>
+            <a:ext cx="5760720" cy="384048"/>
+          </a:xfrm>
+          <a:prstGeom prst="rect">
+            <a:avLst/>
+          </a:prstGeom>
+          <a:solidFill>
+            <a:srgbClr val="EEF4F8"/>
+          </a:solidFill>
+          <a:ln>
+            <a:noFill/>
+          </a:ln>
+          <a:effectLst/>
+        </p:spPr>
+        <p:style>
+          <a:lnRef idx="1">
+            <a:schemeClr val="accent1"/>
+          </a:lnRef>
+          <a:fillRef idx="3">
+            <a:schemeClr val="accent1"/>
+          </a:fillRef>
+          <a:effectRef idx="2">
+            <a:schemeClr val="accent1"/>
+          </a:effectRef>
+          <a:fontRef idx="minor">
+            <a:schemeClr val="lt1"/>
+          </a:fontRef>
+        </p:style>
+        <p:txBody>
+          <a:bodyPr rtlCol="0" anchor="ctr"/>
+          <a:lstStyle/>
+          <a:p>
+            <a:pPr algn="ctr"/>
+          </a:p>
+        </p:txBody>
+      </p:sp>
+      <p:sp>
+        <p:nvSpPr>
+          <p:cNvPr id="17" name="TextBox 16"/>
+          <p:cNvSpPr txBox="1"/>
+          <p:nvPr/>
+        </p:nvSpPr>
+        <p:spPr>
+          <a:xfrm>
+            <a:off x="868680" y="4389120"/>
+            <a:ext cx="2514600" cy="274320"/>
+          </a:xfrm>
+          <a:prstGeom prst="rect">
+            <a:avLst/>
+          </a:prstGeom>
+          <a:noFill/>
+        </p:spPr>
+        <p:txBody>
+          <a:bodyPr wrap="square" anchor="t" lIns="0" rIns="0" tIns="0" bIns="0">
+            <a:spAutoFit/>
+          </a:bodyPr>
+          <a:lstStyle/>
+          <a:p>
+            <a:pPr algn="l">
+              <a:lnSpc>
+                <a:spcPct val="100000"/>
+              </a:lnSpc>
+            </a:pPr>
+            <a:r>
+              <a:rPr sz="1200" b="1">
+                <a:solidFill>
+                  <a:srgbClr val="0E8F86"/>
+                </a:solidFill>
+                <a:latin typeface="Calibri"/>
+              </a:rPr>
+              <a:t>plot_geographic</a:t>
+            </a:r>
+          </a:p>
+        </p:txBody>
+      </p:sp>
+      <p:sp>
+        <p:nvSpPr>
+          <p:cNvPr id="18" name="TextBox 17"/>
+          <p:cNvSpPr txBox="1"/>
+          <p:nvPr/>
+        </p:nvSpPr>
+        <p:spPr>
+          <a:xfrm>
+            <a:off x="3520440" y="4398264"/>
+            <a:ext cx="2788920" cy="274320"/>
+          </a:xfrm>
+          <a:prstGeom prst="rect">
+            <a:avLst/>
+          </a:prstGeom>
+          <a:noFill/>
+        </p:spPr>
+        <p:txBody>
+          <a:bodyPr wrap="square" anchor="t" lIns="0" rIns="0" tIns="0" bIns="0">
+            <a:spAutoFit/>
+          </a:bodyPr>
+          <a:lstStyle/>
+          <a:p>
+            <a:pPr algn="l">
+              <a:lnSpc>
+                <a:spcPct val="100000"/>
+              </a:lnSpc>
+            </a:pPr>
+            <a:r>
+              <a:rPr sz="1100" b="0">
+                <a:solidFill>
+                  <a:srgbClr val="0F172A"/>
+                </a:solidFill>
+                <a:latin typeface="Calibri"/>
+              </a:rPr>
+              <a:t>choropleth, bivariateChoropleth</a:t>
+            </a:r>
+          </a:p>
+        </p:txBody>
+      </p:sp>
+      <p:sp>
+        <p:nvSpPr>
+          <p:cNvPr id="19" name="TextBox 18"/>
+          <p:cNvSpPr txBox="1"/>
+          <p:nvPr/>
+        </p:nvSpPr>
+        <p:spPr>
+          <a:xfrm>
+            <a:off x="868680" y="4800600"/>
+            <a:ext cx="2514600" cy="274320"/>
+          </a:xfrm>
+          <a:prstGeom prst="rect">
+            <a:avLst/>
+          </a:prstGeom>
+          <a:noFill/>
+        </p:spPr>
+        <p:txBody>
+          <a:bodyPr wrap="square" anchor="t" lIns="0" rIns="0" tIns="0" bIns="0">
+            <a:spAutoFit/>
+          </a:bodyPr>
+          <a:lstStyle/>
+          <a:p>
+            <a:pPr algn="l">
+              <a:lnSpc>
+                <a:spcPct val="100000"/>
+              </a:lnSpc>
+            </a:pPr>
+            <a:r>
+              <a:rPr sz="1200" b="1">
+                <a:solidFill>
+                  <a:srgbClr val="0E8F86"/>
+                </a:solidFill>
+                <a:latin typeface="Calibri"/>
+              </a:rPr>
+              <a:t>plot_distribution</a:t>
+            </a:r>
+          </a:p>
+        </p:txBody>
+      </p:sp>
+      <p:sp>
+        <p:nvSpPr>
+          <p:cNvPr id="20" name="TextBox 19"/>
+          <p:cNvSpPr txBox="1"/>
+          <p:nvPr/>
+        </p:nvSpPr>
+        <p:spPr>
+          <a:xfrm>
+            <a:off x="3520440" y="4809744"/>
+            <a:ext cx="2788920" cy="274320"/>
+          </a:xfrm>
+          <a:prstGeom prst="rect">
+            <a:avLst/>
+          </a:prstGeom>
+          <a:noFill/>
+        </p:spPr>
+        <p:txBody>
+          <a:bodyPr wrap="square" anchor="t" lIns="0" rIns="0" tIns="0" bIns="0">
+            <a:spAutoFit/>
+          </a:bodyPr>
+          <a:lstStyle/>
+          <a:p>
+            <a:pPr algn="l">
+              <a:lnSpc>
+                <a:spcPct val="100000"/>
+              </a:lnSpc>
+            </a:pPr>
+            <a:r>
+              <a:rPr sz="1100" b="0">
+                <a:solidFill>
+                  <a:srgbClr val="0F172A"/>
+                </a:solidFill>
+                <a:latin typeface="Calibri"/>
+              </a:rPr>
+              <a:t>beeswarm, box, ridgeline</a:t>
+            </a:r>
+          </a:p>
+        </p:txBody>
+      </p:sp>
+      <p:sp>
+        <p:nvSpPr>
+          <p:cNvPr id="21" name="Rectangle 20"/>
+          <p:cNvSpPr/>
+          <p:nvPr/>
+        </p:nvSpPr>
+        <p:spPr>
+          <a:xfrm>
+            <a:off x="685800" y="5175504"/>
+            <a:ext cx="5760720" cy="384048"/>
+          </a:xfrm>
+          <a:prstGeom prst="rect">
+            <a:avLst/>
+          </a:prstGeom>
+          <a:solidFill>
+            <a:srgbClr val="EEF4F8"/>
+          </a:solidFill>
+          <a:ln>
+            <a:noFill/>
+          </a:ln>
+          <a:effectLst/>
+        </p:spPr>
+        <p:style>
+          <a:lnRef idx="1">
+            <a:schemeClr val="accent1"/>
+          </a:lnRef>
+          <a:fillRef idx="3">
+            <a:schemeClr val="accent1"/>
+          </a:fillRef>
+          <a:effectRef idx="2">
+            <a:schemeClr val="accent1"/>
+          </a:effectRef>
+          <a:fontRef idx="minor">
+            <a:schemeClr val="lt1"/>
+          </a:fontRef>
+        </p:style>
+        <p:txBody>
+          <a:bodyPr rtlCol="0" anchor="ctr"/>
+          <a:lstStyle/>
+          <a:p>
+            <a:pPr algn="ctr"/>
+          </a:p>
+        </p:txBody>
+      </p:sp>
+      <p:sp>
+        <p:nvSpPr>
+          <p:cNvPr id="22" name="TextBox 21"/>
+          <p:cNvSpPr txBox="1"/>
+          <p:nvPr/>
+        </p:nvSpPr>
+        <p:spPr>
+          <a:xfrm>
+            <a:off x="868680" y="5212080"/>
+            <a:ext cx="2514600" cy="274320"/>
+          </a:xfrm>
+          <a:prstGeom prst="rect">
+            <a:avLst/>
+          </a:prstGeom>
+          <a:noFill/>
+        </p:spPr>
+        <p:txBody>
+          <a:bodyPr wrap="square" anchor="t" lIns="0" rIns="0" tIns="0" bIns="0">
+            <a:spAutoFit/>
+          </a:bodyPr>
+          <a:lstStyle/>
+          <a:p>
+            <a:pPr algn="l">
+              <a:lnSpc>
+                <a:spcPct val="100000"/>
+              </a:lnSpc>
+            </a:pPr>
+            <a:r>
+              <a:rPr sz="1200" b="1">
+                <a:solidFill>
+                  <a:srgbClr val="0E8F86"/>
+                </a:solidFill>
+                <a:latin typeface="Calibri"/>
+              </a:rPr>
+              <a:t>show_headline</a:t>
+            </a:r>
+          </a:p>
+        </p:txBody>
+      </p:sp>
+      <p:sp>
+        <p:nvSpPr>
+          <p:cNvPr id="23" name="TextBox 22"/>
+          <p:cNvSpPr txBox="1"/>
+          <p:nvPr/>
+        </p:nvSpPr>
+        <p:spPr>
+          <a:xfrm>
+            <a:off x="3520440" y="5221224"/>
+            <a:ext cx="2788920" cy="274320"/>
+          </a:xfrm>
+          <a:prstGeom prst="rect">
+            <a:avLst/>
+          </a:prstGeom>
+          <a:noFill/>
+        </p:spPr>
+        <p:txBody>
+          <a:bodyPr wrap="square" anchor="t" lIns="0" rIns="0" tIns="0" bIns="0">
+            <a:spAutoFit/>
+          </a:bodyPr>
+          <a:lstStyle/>
+          <a:p>
+            <a:pPr algn="l">
+              <a:lnSpc>
+                <a:spcPct val="100000"/>
+              </a:lnSpc>
+            </a:pPr>
+            <a:r>
+              <a:rPr sz="1100" b="0">
+                <a:solidFill>
+                  <a:srgbClr val="0F172A"/>
+                </a:solidFill>
+                <a:latin typeface="Calibri"/>
+              </a:rPr>
+              <a:t>statTile</a:t>
+            </a:r>
+          </a:p>
+        </p:txBody>
+      </p:sp>
+      <p:sp>
+        <p:nvSpPr>
+          <p:cNvPr id="24" name="TextBox 23"/>
+          <p:cNvSpPr txBox="1"/>
+          <p:nvPr/>
+        </p:nvSpPr>
+        <p:spPr>
+          <a:xfrm>
+            <a:off x="685800" y="5614416"/>
+            <a:ext cx="5760720" cy="274320"/>
+          </a:xfrm>
+          <a:prstGeom prst="rect">
+            <a:avLst/>
+          </a:prstGeom>
+          <a:noFill/>
+        </p:spPr>
+        <p:txBody>
+          <a:bodyPr wrap="square" anchor="t" lIns="0" rIns="0" tIns="0" bIns="0">
+            <a:spAutoFit/>
+          </a:bodyPr>
+          <a:lstStyle/>
+          <a:p>
+            <a:pPr algn="l">
+              <a:lnSpc>
+                <a:spcPct val="100000"/>
+              </a:lnSpc>
+            </a:pPr>
+            <a:r>
+              <a:rPr sz="1050" b="0">
+                <a:solidFill>
+                  <a:srgbClr val="526173"/>
+                </a:solidFill>
+                <a:latin typeface="Calibri"/>
+              </a:rPr>
+              <a:t>The form enum is documented with the validator's own rule text, so a tool description cannot drift from the rule it promises.</a:t>
+            </a:r>
+          </a:p>
+        </p:txBody>
+      </p:sp>
+      <p:sp>
+        <p:nvSpPr>
+          <p:cNvPr id="25" name="TextBox 24"/>
+          <p:cNvSpPr txBox="1"/>
+          <p:nvPr/>
+        </p:nvSpPr>
+        <p:spPr>
+          <a:xfrm>
+            <a:off x="6720840" y="2395728"/>
+            <a:ext cx="4782312" cy="274320"/>
+          </a:xfrm>
+          <a:prstGeom prst="rect">
+            <a:avLst/>
+          </a:prstGeom>
+          <a:noFill/>
+        </p:spPr>
+        <p:txBody>
+          <a:bodyPr wrap="square" anchor="t" lIns="0" rIns="0" tIns="0" bIns="0">
+            <a:spAutoFit/>
+          </a:bodyPr>
+          <a:lstStyle/>
+          <a:p>
+            <a:pPr algn="l">
+              <a:lnSpc>
+                <a:spcPct val="100000"/>
+              </a:lnSpc>
+            </a:pPr>
+            <a:r>
+              <a:rPr sz="1000" b="1">
+                <a:solidFill>
+                  <a:srgbClr val="526173"/>
+                </a:solidFill>
+                <a:latin typeface="Arial"/>
+              </a:rPr>
+              <a:t>READ TOOLS (3)  —  what makes it an agent, not a classifier</a:t>
+            </a:r>
+          </a:p>
+        </p:txBody>
+      </p:sp>
+      <p:sp>
+        <p:nvSpPr>
+          <p:cNvPr id="26" name="Rectangle 25"/>
+          <p:cNvSpPr/>
+          <p:nvPr/>
+        </p:nvSpPr>
+        <p:spPr>
+          <a:xfrm>
+            <a:off x="6720840" y="2706624"/>
+            <a:ext cx="38100" cy="694944"/>
           </a:xfrm>
           <a:prstGeom prst="rect">
             <a:avLst/>
@@ -9571,14 +10380,14 @@
       </p:sp>
       <p:sp>
         <p:nvSpPr>
-          <p:cNvPr id="7" name="TextBox 6"/>
+          <p:cNvPr id="27" name="TextBox 26"/>
           <p:cNvSpPr txBox="1"/>
           <p:nvPr/>
         </p:nvSpPr>
         <p:spPr>
           <a:xfrm>
-            <a:off x="923544" y="2286000"/>
-            <a:ext cx="2926080" cy="914400"/>
+            <a:off x="6949440" y="2743200"/>
+            <a:ext cx="4480560" cy="658368"/>
           </a:xfrm>
           <a:prstGeom prst="rect">
             <a:avLst/>
@@ -9597,13 +10406,13 @@
               </a:lnSpc>
             </a:pPr>
             <a:r>
-              <a:rPr sz="1100" b="1">
+              <a:rPr sz="1200" b="1">
                 <a:solidFill>
                   <a:srgbClr val="1E66B8"/>
                 </a:solidFill>
-                <a:latin typeface="Arial"/>
-              </a:rPr>
-              <a:t>applicability.py   ·   computed</a:t>
+                <a:latin typeface="Calibri"/>
+              </a:rPr>
+              <a:t>describe_dataset</a:t>
             </a:r>
           </a:p>
           <a:p>
@@ -9612,31 +10421,75 @@
                 <a:spcPct val="114000"/>
               </a:lnSpc>
               <a:spcBef>
-                <a:spcPts val="400"/>
+                <a:spcPts val="300"/>
               </a:spcBef>
             </a:pPr>
             <a:r>
-              <a:rPr sz="1200" b="0">
+              <a:rPr sz="1100" b="0">
                 <a:solidFill>
                   <a:srgbClr val="0F172A"/>
                 </a:solidFill>
                 <a:latin typeface="Calibri"/>
               </a:rPr>
-              <a:t>which forms this table can carry</a:t>
-            </a:r>
-          </a:p>
-        </p:txBody>
-      </p:sp>
-      <p:sp>
-        <p:nvSpPr>
-          <p:cNvPr id="8" name="TextBox 7"/>
+              <a:t>dimensions, measures, span, row count, missingness, and the magnitude ratio between measures</a:t>
+            </a:r>
+          </a:p>
+        </p:txBody>
+      </p:sp>
+      <p:sp>
+        <p:nvSpPr>
+          <p:cNvPr id="28" name="Rectangle 27"/>
+          <p:cNvSpPr/>
+          <p:nvPr/>
+        </p:nvSpPr>
+        <p:spPr>
+          <a:xfrm>
+            <a:off x="6720840" y="3493008"/>
+            <a:ext cx="38100" cy="694944"/>
+          </a:xfrm>
+          <a:prstGeom prst="rect">
+            <a:avLst/>
+          </a:prstGeom>
+          <a:solidFill>
+            <a:srgbClr val="1E66B8"/>
+          </a:solidFill>
+          <a:ln>
+            <a:noFill/>
+          </a:ln>
+          <a:effectLst/>
+        </p:spPr>
+        <p:style>
+          <a:lnRef idx="1">
+            <a:schemeClr val="accent1"/>
+          </a:lnRef>
+          <a:fillRef idx="3">
+            <a:schemeClr val="accent1"/>
+          </a:fillRef>
+          <a:effectRef idx="2">
+            <a:schemeClr val="accent1"/>
+          </a:effectRef>
+          <a:fontRef idx="minor">
+            <a:schemeClr val="lt1"/>
+          </a:fontRef>
+        </p:style>
+        <p:txBody>
+          <a:bodyPr rtlCol="0" anchor="ctr"/>
+          <a:lstStyle/>
+          <a:p>
+            <a:pPr algn="ctr"/>
+          </a:p>
+        </p:txBody>
+      </p:sp>
+      <p:sp>
+        <p:nvSpPr>
+          <p:cNvPr id="29" name="TextBox 28"/>
           <p:cNvSpPr txBox="1"/>
           <p:nvPr/>
         </p:nvSpPr>
         <p:spPr>
           <a:xfrm>
-            <a:off x="4123944" y="2542032"/>
-            <a:ext cx="274320" cy="365760"/>
+            <a:off x="6949440" y="3529584"/>
+            <a:ext cx="4480560" cy="658368"/>
           </a:xfrm>
           <a:prstGeom prst="rect">
             <a:avLst/>
@@ -9651,31 +10504,152 @@
           <a:p>
             <a:pPr algn="l">
               <a:lnSpc>
-                <a:spcPct val="100000"/>
-              </a:lnSpc>
-            </a:pPr>
-            <a:r>
-              <a:rPr sz="2000" b="1">
-                <a:solidFill>
-                  <a:srgbClr val="D9DFE7"/>
-                </a:solidFill>
-                <a:latin typeface="Arial"/>
-              </a:rPr>
-              <a:t>›</a:t>
-            </a:r>
-          </a:p>
-        </p:txBody>
-      </p:sp>
-      <p:sp>
-        <p:nvSpPr>
-          <p:cNvPr id="9" name="Rectangle 8"/>
+                <a:spcPct val="114000"/>
+              </a:lnSpc>
+            </a:pPr>
+            <a:r>
+              <a:rPr sz="1200" b="1">
+                <a:solidFill>
+                  <a:srgbClr val="1E66B8"/>
+                </a:solidFill>
+                <a:latin typeface="Calibri"/>
+              </a:rPr>
+              <a:t>get_series</a:t>
+            </a:r>
+          </a:p>
+          <a:p>
+            <a:pPr algn="l">
+              <a:lnSpc>
+                <a:spcPct val="114000"/>
+              </a:lnSpc>
+              <a:spcBef>
+                <a:spcPts val="300"/>
+              </a:spcBef>
+            </a:pPr>
+            <a:r>
+              <a:rPr sz="1100" b="0">
+                <a:solidFill>
+                  <a:srgbClr val="0F172A"/>
+                </a:solidFill>
+                <a:latin typeface="Calibri"/>
+              </a:rPr>
+              <a:t>a ChartFrame for one measure, grouped, filtered and aggregated as asked</a:t>
+            </a:r>
+          </a:p>
+        </p:txBody>
+      </p:sp>
+      <p:sp>
+        <p:nvSpPr>
+          <p:cNvPr id="30" name="Rectangle 29"/>
           <p:cNvSpPr/>
           <p:nvPr/>
         </p:nvSpPr>
         <p:spPr>
           <a:xfrm>
-            <a:off x="4398264" y="2103120"/>
-            <a:ext cx="3401568" cy="1170432"/>
+            <a:off x="6720840" y="4279392"/>
+            <a:ext cx="38100" cy="694944"/>
+          </a:xfrm>
+          <a:prstGeom prst="rect">
+            <a:avLst/>
+          </a:prstGeom>
+          <a:solidFill>
+            <a:srgbClr val="1E66B8"/>
+          </a:solidFill>
+          <a:ln>
+            <a:noFill/>
+          </a:ln>
+          <a:effectLst/>
+        </p:spPr>
+        <p:style>
+          <a:lnRef idx="1">
+            <a:schemeClr val="accent1"/>
+          </a:lnRef>
+          <a:fillRef idx="3">
+            <a:schemeClr val="accent1"/>
+          </a:fillRef>
+          <a:effectRef idx="2">
+            <a:schemeClr val="accent1"/>
+          </a:effectRef>
+          <a:fontRef idx="minor">
+            <a:schemeClr val="lt1"/>
+          </a:fontRef>
+        </p:style>
+        <p:txBody>
+          <a:bodyPr rtlCol="0" anchor="ctr"/>
+          <a:lstStyle/>
+          <a:p>
+            <a:pPr algn="ctr"/>
+          </a:p>
+        </p:txBody>
+      </p:sp>
+      <p:sp>
+        <p:nvSpPr>
+          <p:cNvPr id="31" name="TextBox 30"/>
+          <p:cNvSpPr txBox="1"/>
+          <p:nvPr/>
+        </p:nvSpPr>
+        <p:spPr>
+          <a:xfrm>
+            <a:off x="6949440" y="4315968"/>
+            <a:ext cx="4480560" cy="658368"/>
+          </a:xfrm>
+          <a:prstGeom prst="rect">
+            <a:avLst/>
+          </a:prstGeom>
+          <a:noFill/>
+        </p:spPr>
+        <p:txBody>
+          <a:bodyPr wrap="square" anchor="t" lIns="0" rIns="0" tIns="0" bIns="0">
+            <a:spAutoFit/>
+          </a:bodyPr>
+          <a:lstStyle/>
+          <a:p>
+            <a:pPr algn="l">
+              <a:lnSpc>
+                <a:spcPct val="114000"/>
+              </a:lnSpc>
+            </a:pPr>
+            <a:r>
+              <a:rPr sz="1200" b="1">
+                <a:solidFill>
+                  <a:srgbClr val="1E66B8"/>
+                </a:solidFill>
+                <a:latin typeface="Calibri"/>
+              </a:rPr>
+              <a:t>check_comparability</a:t>
+            </a:r>
+          </a:p>
+          <a:p>
+            <a:pPr algn="l">
+              <a:lnSpc>
+                <a:spcPct val="114000"/>
+              </a:lnSpc>
+              <a:spcBef>
+                <a:spcPts val="300"/>
+              </a:spcBef>
+            </a:pPr>
+            <a:r>
+              <a:rPr sz="1100" b="0">
+                <a:solidFill>
+                  <a:srgbClr val="0F172A"/>
+                </a:solidFill>
+                <a:latin typeface="Calibri"/>
+              </a:rPr>
+              <a:t>whether a per-capita denominator exists — and whether it is needed</a:t>
+            </a:r>
+          </a:p>
+        </p:txBody>
+      </p:sp>
+      <p:sp>
+        <p:nvSpPr>
+          <p:cNvPr id="32" name="Rectangle 31"/>
+          <p:cNvSpPr/>
+          <p:nvPr/>
+        </p:nvSpPr>
+        <p:spPr>
+          <a:xfrm>
+            <a:off x="6720840" y="5175504"/>
+            <a:ext cx="4782312" cy="822960"/>
           </a:xfrm>
           <a:prstGeom prst="rect">
             <a:avLst/>
@@ -9712,14 +10686,14 @@
       </p:sp>
       <p:sp>
         <p:nvSpPr>
-          <p:cNvPr id="10" name="Rectangle 9"/>
+          <p:cNvPr id="33" name="Rectangle 32"/>
           <p:cNvSpPr/>
           <p:nvPr/>
         </p:nvSpPr>
         <p:spPr>
           <a:xfrm>
-            <a:off x="4398264" y="2103120"/>
-            <a:ext cx="3401568" cy="50800"/>
+            <a:off x="6720840" y="5175504"/>
+            <a:ext cx="44450" cy="822960"/>
           </a:xfrm>
           <a:prstGeom prst="rect">
             <a:avLst/>
@@ -9756,14 +10730,14 @@
       </p:sp>
       <p:sp>
         <p:nvSpPr>
-          <p:cNvPr id="11" name="TextBox 10"/>
+          <p:cNvPr id="34" name="TextBox 33"/>
           <p:cNvSpPr txBox="1"/>
           <p:nvPr/>
         </p:nvSpPr>
         <p:spPr>
           <a:xfrm>
-            <a:off x="4636007" y="2286000"/>
-            <a:ext cx="2926080" cy="914400"/>
+            <a:off x="6967728" y="5321808"/>
+            <a:ext cx="4343400" cy="594360"/>
           </a:xfrm>
           <a:prstGeom prst="rect">
             <a:avLst/>
@@ -9782,46 +10756,27 @@
               </a:lnSpc>
             </a:pPr>
             <a:r>
-              <a:rPr sz="1100" b="1">
-                <a:solidFill>
-                  <a:srgbClr val="20C4B0"/>
-                </a:solidFill>
-                <a:latin typeface="Arial"/>
-              </a:rPr>
-              <a:t>the model   ·   decided</a:t>
-            </a:r>
-          </a:p>
-          <a:p>
-            <a:pPr algn="l">
-              <a:lnSpc>
-                <a:spcPct val="114000"/>
-              </a:lnSpc>
-              <a:spcBef>
-                <a:spcPts val="400"/>
-              </a:spcBef>
-            </a:pPr>
-            <a:r>
-              <a:rPr sz="1200" b="0">
+              <a:rPr sz="1100" b="0">
                 <a:solidFill>
                   <a:srgbClr val="0F172A"/>
                 </a:solidFill>
                 <a:latin typeface="Calibri"/>
               </a:rPr>
-              <a:t>which of those are worth showing, and why</a:t>
-            </a:r>
-          </a:p>
-        </p:txBody>
-      </p:sp>
-      <p:sp>
-        <p:nvSpPr>
-          <p:cNvPr id="12" name="TextBox 11"/>
+              <a:t>Without the read tools the model picks a form blind from a prompt string. With them it can discover that two measures differ by 100× and derive that it needs an indexed transform.</a:t>
+            </a:r>
+          </a:p>
+        </p:txBody>
+      </p:sp>
+      <p:sp>
+        <p:nvSpPr>
+          <p:cNvPr id="35" name="TextBox 34"/>
           <p:cNvSpPr txBox="1"/>
           <p:nvPr/>
         </p:nvSpPr>
         <p:spPr>
           <a:xfrm>
-            <a:off x="7836408" y="2542032"/>
-            <a:ext cx="274320" cy="365760"/>
+            <a:off x="685800" y="6053328"/>
+            <a:ext cx="10789920" cy="256032"/>
           </a:xfrm>
           <a:prstGeom prst="rect">
             <a:avLst/>
@@ -9840,115 +10795,27 @@
               </a:lnSpc>
             </a:pPr>
             <a:r>
-              <a:rPr sz="2000" b="1">
-                <a:solidFill>
-                  <a:srgbClr val="D9DFE7"/>
-                </a:solidFill>
-                <a:latin typeface="Arial"/>
-              </a:rPr>
-              <a:t>›</a:t>
-            </a:r>
-          </a:p>
-        </p:txBody>
-      </p:sp>
-      <p:sp>
-        <p:nvSpPr>
-          <p:cNvPr id="13" name="Rectangle 12"/>
-          <p:cNvSpPr/>
-          <p:nvPr/>
-        </p:nvSpPr>
-        <p:spPr>
-          <a:xfrm>
-            <a:off x="8110727" y="2103120"/>
-            <a:ext cx="3401568" cy="1170432"/>
-          </a:xfrm>
-          <a:prstGeom prst="rect">
-            <a:avLst/>
-          </a:prstGeom>
-          <a:solidFill>
-            <a:srgbClr val="EEF4F8"/>
-          </a:solidFill>
-          <a:ln>
-            <a:noFill/>
-          </a:ln>
-          <a:effectLst/>
-        </p:spPr>
-        <p:style>
-          <a:lnRef idx="1">
-            <a:schemeClr val="accent1"/>
-          </a:lnRef>
-          <a:fillRef idx="3">
-            <a:schemeClr val="accent1"/>
-          </a:fillRef>
-          <a:effectRef idx="2">
-            <a:schemeClr val="accent1"/>
-          </a:effectRef>
-          <a:fontRef idx="minor">
-            <a:schemeClr val="lt1"/>
-          </a:fontRef>
-        </p:style>
-        <p:txBody>
-          <a:bodyPr rtlCol="0" anchor="ctr"/>
-          <a:lstStyle/>
-          <a:p>
-            <a:pPr algn="ctr"/>
-          </a:p>
-        </p:txBody>
-      </p:sp>
-      <p:sp>
-        <p:nvSpPr>
-          <p:cNvPr id="14" name="Rectangle 13"/>
-          <p:cNvSpPr/>
-          <p:nvPr/>
-        </p:nvSpPr>
-        <p:spPr>
-          <a:xfrm>
-            <a:off x="8110727" y="2103120"/>
-            <a:ext cx="3401568" cy="50800"/>
-          </a:xfrm>
-          <a:prstGeom prst="rect">
-            <a:avLst/>
-          </a:prstGeom>
-          <a:solidFill>
-            <a:srgbClr val="0D1B5C"/>
-          </a:solidFill>
-          <a:ln>
-            <a:noFill/>
-          </a:ln>
-          <a:effectLst/>
-        </p:spPr>
-        <p:style>
-          <a:lnRef idx="1">
-            <a:schemeClr val="accent1"/>
-          </a:lnRef>
-          <a:fillRef idx="3">
-            <a:schemeClr val="accent1"/>
-          </a:fillRef>
-          <a:effectRef idx="2">
-            <a:schemeClr val="accent1"/>
-          </a:effectRef>
-          <a:fontRef idx="minor">
-            <a:schemeClr val="lt1"/>
-          </a:fontRef>
-        </p:style>
-        <p:txBody>
-          <a:bodyPr rtlCol="0" anchor="ctr"/>
-          <a:lstStyle/>
-          <a:p>
-            <a:pPr algn="ctr"/>
-          </a:p>
-        </p:txBody>
-      </p:sp>
-      <p:sp>
-        <p:nvSpPr>
-          <p:cNvPr id="15" name="TextBox 14"/>
+              <a:rPr sz="1000" b="0">
+                <a:solidFill>
+                  <a:srgbClr val="526173"/>
+                </a:solidFill>
+                <a:latin typeface="Calibri"/>
+              </a:rPr>
+              <a:t>Defined in docs/CHART_CONTRACT.md and pinned by the generated docs/chart-schema.json. Today the selector makes one structured call; the tool loop is the next step.</a:t>
+            </a:r>
+          </a:p>
+        </p:txBody>
+      </p:sp>
+      <p:sp>
+        <p:nvSpPr>
+          <p:cNvPr id="36" name="TextBox 35"/>
           <p:cNvSpPr txBox="1"/>
           <p:nvPr/>
         </p:nvSpPr>
         <p:spPr>
           <a:xfrm>
-            <a:off x="8348471" y="2286000"/>
-            <a:ext cx="2926080" cy="914400"/>
+            <a:off x="685800" y="6355080"/>
+            <a:ext cx="8686800" cy="274320"/>
           </a:xfrm>
           <a:prstGeom prst="rect">
             <a:avLst/>
@@ -9963,639 +10830,16 @@
           <a:p>
             <a:pPr algn="l">
               <a:lnSpc>
-                <a:spcPct val="114000"/>
-              </a:lnSpc>
-            </a:pPr>
-            <a:r>
-              <a:rPr sz="1100" b="1">
-                <a:solidFill>
-                  <a:srgbClr val="0D1B5C"/>
-                </a:solidFill>
-                <a:latin typeface="Arial"/>
-              </a:rPr>
-              <a:t>validate.py   ·   computed</a:t>
-            </a:r>
-          </a:p>
-          <a:p>
-            <a:pPr algn="l">
-              <a:lnSpc>
-                <a:spcPct val="114000"/>
-              </a:lnSpc>
-              <a:spcBef>
-                <a:spcPts val="400"/>
-              </a:spcBef>
-            </a:pPr>
-            <a:r>
-              <a:rPr sz="1200" b="0">
-                <a:solidFill>
-                  <a:srgbClr val="0F172A"/>
+                <a:spcPct val="100000"/>
+              </a:lnSpc>
+            </a:pPr>
+            <a:r>
+              <a:rPr sz="900" b="0">
+                <a:solidFill>
+                  <a:srgbClr val="526173"/>
                 </a:solidFill>
                 <a:latin typeface="Calibri"/>
               </a:rPr>
-              <a:t>whether the spec is honest</a:t>
-            </a:r>
-          </a:p>
-        </p:txBody>
-      </p:sp>
-      <p:sp>
-        <p:nvSpPr>
-          <p:cNvPr id="16" name="TextBox 15"/>
-          <p:cNvSpPr txBox="1"/>
-          <p:nvPr/>
-        </p:nvSpPr>
-        <p:spPr>
-          <a:xfrm>
-            <a:off x="685800" y="3401568"/>
-            <a:ext cx="10789920" cy="274320"/>
-          </a:xfrm>
-          <a:prstGeom prst="rect">
-            <a:avLst/>
-          </a:prstGeom>
-          <a:noFill/>
-        </p:spPr>
-        <p:txBody>
-          <a:bodyPr wrap="square" anchor="t" lIns="0" rIns="0" tIns="0" bIns="0">
-            <a:spAutoFit/>
-          </a:bodyPr>
-          <a:lstStyle/>
-          <a:p>
-            <a:pPr algn="l">
-              <a:lnSpc>
-                <a:spcPct val="100000"/>
-              </a:lnSpc>
-            </a:pPr>
-            <a:r>
-              <a:rPr sz="1150" b="0">
-                <a:solidFill>
-                  <a:srgbClr val="526173"/>
-                </a:solidFill>
-                <a:latin typeface="Calibri"/>
-              </a:rPr>
-              <a:t>Computing what is possible before asking what is best is what makes this work on a local model: the prompt shrinks from seventeen forms with their rules to a handful of pre-validated candidates.</a:t>
-            </a:r>
-          </a:p>
-        </p:txBody>
-      </p:sp>
-      <p:sp>
-        <p:nvSpPr>
-          <p:cNvPr id="17" name="Rectangle 16"/>
-          <p:cNvSpPr/>
-          <p:nvPr/>
-        </p:nvSpPr>
-        <p:spPr>
-          <a:xfrm>
-            <a:off x="685800" y="3840480"/>
-            <a:ext cx="6949440" cy="2194560"/>
-          </a:xfrm>
-          <a:prstGeom prst="rect">
-            <a:avLst/>
-          </a:prstGeom>
-          <a:solidFill>
-            <a:srgbClr val="EEF4F8"/>
-          </a:solidFill>
-          <a:ln>
-            <a:noFill/>
-          </a:ln>
-          <a:effectLst/>
-        </p:spPr>
-        <p:style>
-          <a:lnRef idx="1">
-            <a:schemeClr val="accent1"/>
-          </a:lnRef>
-          <a:fillRef idx="3">
-            <a:schemeClr val="accent1"/>
-          </a:fillRef>
-          <a:effectRef idx="2">
-            <a:schemeClr val="accent1"/>
-          </a:effectRef>
-          <a:fontRef idx="minor">
-            <a:schemeClr val="lt1"/>
-          </a:fontRef>
-        </p:style>
-        <p:txBody>
-          <a:bodyPr rtlCol="0" anchor="ctr"/>
-          <a:lstStyle/>
-          <a:p>
-            <a:pPr algn="ctr"/>
-          </a:p>
-        </p:txBody>
-      </p:sp>
-      <p:sp>
-        <p:nvSpPr>
-          <p:cNvPr id="18" name="Rectangle 17"/>
-          <p:cNvSpPr/>
-          <p:nvPr/>
-        </p:nvSpPr>
-        <p:spPr>
-          <a:xfrm>
-            <a:off x="685800" y="3840480"/>
-            <a:ext cx="6949440" cy="50800"/>
-          </a:xfrm>
-          <a:prstGeom prst="rect">
-            <a:avLst/>
-          </a:prstGeom>
-          <a:solidFill>
-            <a:srgbClr val="0E8F86"/>
-          </a:solidFill>
-          <a:ln>
-            <a:noFill/>
-          </a:ln>
-          <a:effectLst/>
-        </p:spPr>
-        <p:style>
-          <a:lnRef idx="1">
-            <a:schemeClr val="accent1"/>
-          </a:lnRef>
-          <a:fillRef idx="3">
-            <a:schemeClr val="accent1"/>
-          </a:fillRef>
-          <a:effectRef idx="2">
-            <a:schemeClr val="accent1"/>
-          </a:effectRef>
-          <a:fontRef idx="minor">
-            <a:schemeClr val="lt1"/>
-          </a:fontRef>
-        </p:style>
-        <p:txBody>
-          <a:bodyPr rtlCol="0" anchor="ctr"/>
-          <a:lstStyle/>
-          <a:p>
-            <a:pPr algn="ctr"/>
-          </a:p>
-        </p:txBody>
-      </p:sp>
-      <p:sp>
-        <p:nvSpPr>
-          <p:cNvPr id="19" name="TextBox 18"/>
-          <p:cNvSpPr txBox="1"/>
-          <p:nvPr/>
-        </p:nvSpPr>
-        <p:spPr>
-          <a:xfrm>
-            <a:off x="932688" y="4041648"/>
-            <a:ext cx="6492240" cy="365760"/>
-          </a:xfrm>
-          <a:prstGeom prst="rect">
-            <a:avLst/>
-          </a:prstGeom>
-          <a:noFill/>
-        </p:spPr>
-        <p:txBody>
-          <a:bodyPr wrap="square" anchor="t" lIns="0" rIns="0" tIns="0" bIns="0">
-            <a:spAutoFit/>
-          </a:bodyPr>
-          <a:lstStyle/>
-          <a:p>
-            <a:pPr algn="l">
-              <a:lnSpc>
-                <a:spcPct val="100000"/>
-              </a:lnSpc>
-            </a:pPr>
-            <a:r>
-              <a:rPr sz="1000" b="1">
-                <a:solidFill>
-                  <a:srgbClr val="526173"/>
-                </a:solidFill>
-                <a:latin typeface="Arial"/>
-              </a:rPr>
-              <a:t>THE MCP-SHAPED TOOL SURFACE</a:t>
-            </a:r>
-          </a:p>
-        </p:txBody>
-      </p:sp>
-      <p:sp>
-        <p:nvSpPr>
-          <p:cNvPr id="20" name="TextBox 19"/>
-          <p:cNvSpPr txBox="1"/>
-          <p:nvPr/>
-        </p:nvSpPr>
-        <p:spPr>
-          <a:xfrm>
-            <a:off x="932688" y="4370832"/>
-            <a:ext cx="1828800" cy="274320"/>
-          </a:xfrm>
-          <a:prstGeom prst="rect">
-            <a:avLst/>
-          </a:prstGeom>
-          <a:noFill/>
-        </p:spPr>
-        <p:txBody>
-          <a:bodyPr wrap="square" anchor="t" lIns="0" rIns="0" tIns="0" bIns="0">
-            <a:spAutoFit/>
-          </a:bodyPr>
-          <a:lstStyle/>
-          <a:p>
-            <a:pPr algn="l">
-              <a:lnSpc>
-                <a:spcPct val="100000"/>
-              </a:lnSpc>
-            </a:pPr>
-            <a:r>
-              <a:rPr sz="1150" b="1">
-                <a:solidFill>
-                  <a:srgbClr val="0E8F86"/>
-                </a:solidFill>
-                <a:latin typeface="Calibri"/>
-              </a:rPr>
-              <a:t>7 chart tools</a:t>
-            </a:r>
-          </a:p>
-        </p:txBody>
-      </p:sp>
-      <p:sp>
-        <p:nvSpPr>
-          <p:cNvPr id="21" name="TextBox 20"/>
-          <p:cNvSpPr txBox="1"/>
-          <p:nvPr/>
-        </p:nvSpPr>
-        <p:spPr>
-          <a:xfrm>
-            <a:off x="2651760" y="4370832"/>
-            <a:ext cx="4754880" cy="502920"/>
-          </a:xfrm>
-          <a:prstGeom prst="rect">
-            <a:avLst/>
-          </a:prstGeom>
-          <a:noFill/>
-        </p:spPr>
-        <p:txBody>
-          <a:bodyPr wrap="square" anchor="t" lIns="0" rIns="0" tIns="0" bIns="0">
-            <a:spAutoFit/>
-          </a:bodyPr>
-          <a:lstStyle/>
-          <a:p>
-            <a:pPr algn="l">
-              <a:lnSpc>
-                <a:spcPct val="112000"/>
-              </a:lnSpc>
-            </a:pPr>
-            <a:r>
-              <a:rPr sz="1100" b="0">
-                <a:solidFill>
-                  <a:srgbClr val="0F172A"/>
-                </a:solidFill>
-                <a:latin typeface="Calibri"/>
-              </a:rPr>
-              <a:t>plot_trend_over_time, plot_magnitude, plot_change, plot_relationship, plot_geographic, plot_distribution, show_headline</a:t>
-            </a:r>
-          </a:p>
-        </p:txBody>
-      </p:sp>
-      <p:sp>
-        <p:nvSpPr>
-          <p:cNvPr id="22" name="TextBox 21"/>
-          <p:cNvSpPr txBox="1"/>
-          <p:nvPr/>
-        </p:nvSpPr>
-        <p:spPr>
-          <a:xfrm>
-            <a:off x="932688" y="4901184"/>
-            <a:ext cx="1828800" cy="274320"/>
-          </a:xfrm>
-          <a:prstGeom prst="rect">
-            <a:avLst/>
-          </a:prstGeom>
-          <a:noFill/>
-        </p:spPr>
-        <p:txBody>
-          <a:bodyPr wrap="square" anchor="t" lIns="0" rIns="0" tIns="0" bIns="0">
-            <a:spAutoFit/>
-          </a:bodyPr>
-          <a:lstStyle/>
-          <a:p>
-            <a:pPr algn="l">
-              <a:lnSpc>
-                <a:spcPct val="100000"/>
-              </a:lnSpc>
-            </a:pPr>
-            <a:r>
-              <a:rPr sz="1150" b="1">
-                <a:solidFill>
-                  <a:srgbClr val="0E8F86"/>
-                </a:solidFill>
-                <a:latin typeface="Calibri"/>
-              </a:rPr>
-              <a:t>3 read tools</a:t>
-            </a:r>
-          </a:p>
-        </p:txBody>
-      </p:sp>
-      <p:sp>
-        <p:nvSpPr>
-          <p:cNvPr id="23" name="TextBox 22"/>
-          <p:cNvSpPr txBox="1"/>
-          <p:nvPr/>
-        </p:nvSpPr>
-        <p:spPr>
-          <a:xfrm>
-            <a:off x="2651760" y="4901184"/>
-            <a:ext cx="4754880" cy="502920"/>
-          </a:xfrm>
-          <a:prstGeom prst="rect">
-            <a:avLst/>
-          </a:prstGeom>
-          <a:noFill/>
-        </p:spPr>
-        <p:txBody>
-          <a:bodyPr wrap="square" anchor="t" lIns="0" rIns="0" tIns="0" bIns="0">
-            <a:spAutoFit/>
-          </a:bodyPr>
-          <a:lstStyle/>
-          <a:p>
-            <a:pPr algn="l">
-              <a:lnSpc>
-                <a:spcPct val="112000"/>
-              </a:lnSpc>
-            </a:pPr>
-            <a:r>
-              <a:rPr sz="1100" b="0">
-                <a:solidFill>
-                  <a:srgbClr val="0F172A"/>
-                </a:solidFill>
-                <a:latin typeface="Calibri"/>
-              </a:rPr>
-              <a:t>what makes it an agent rather than a classifier: it can look at the table before it commits to a figure</a:t>
-            </a:r>
-          </a:p>
-        </p:txBody>
-      </p:sp>
-      <p:sp>
-        <p:nvSpPr>
-          <p:cNvPr id="24" name="TextBox 23"/>
-          <p:cNvSpPr txBox="1"/>
-          <p:nvPr/>
-        </p:nvSpPr>
-        <p:spPr>
-          <a:xfrm>
-            <a:off x="932688" y="5431536"/>
-            <a:ext cx="1828800" cy="274320"/>
-          </a:xfrm>
-          <a:prstGeom prst="rect">
-            <a:avLst/>
-          </a:prstGeom>
-          <a:noFill/>
-        </p:spPr>
-        <p:txBody>
-          <a:bodyPr wrap="square" anchor="t" lIns="0" rIns="0" tIns="0" bIns="0">
-            <a:spAutoFit/>
-          </a:bodyPr>
-          <a:lstStyle/>
-          <a:p>
-            <a:pPr algn="l">
-              <a:lnSpc>
-                <a:spcPct val="100000"/>
-              </a:lnSpc>
-            </a:pPr>
-            <a:r>
-              <a:rPr sz="1150" b="1">
-                <a:solidFill>
-                  <a:srgbClr val="0E8F86"/>
-                </a:solidFill>
-                <a:latin typeface="Calibri"/>
-              </a:rPr>
-              <a:t>A two-level decision</a:t>
-            </a:r>
-          </a:p>
-        </p:txBody>
-      </p:sp>
-      <p:sp>
-        <p:nvSpPr>
-          <p:cNvPr id="25" name="TextBox 24"/>
-          <p:cNvSpPr txBox="1"/>
-          <p:nvPr/>
-        </p:nvSpPr>
-        <p:spPr>
-          <a:xfrm>
-            <a:off x="2651760" y="5431536"/>
-            <a:ext cx="4754880" cy="502920"/>
-          </a:xfrm>
-          <a:prstGeom prst="rect">
-            <a:avLst/>
-          </a:prstGeom>
-          <a:noFill/>
-        </p:spPr>
-        <p:txBody>
-          <a:bodyPr wrap="square" anchor="t" lIns="0" rIns="0" tIns="0" bIns="0">
-            <a:spAutoFit/>
-          </a:bodyPr>
-          <a:lstStyle/>
-          <a:p>
-            <a:pPr algn="l">
-              <a:lnSpc>
-                <a:spcPct val="112000"/>
-              </a:lnSpc>
-            </a:pPr>
-            <a:r>
-              <a:rPr sz="1100" b="0">
-                <a:solidFill>
-                  <a:srgbClr val="0F172A"/>
-                </a:solidFill>
-                <a:latin typeface="Calibri"/>
-              </a:rPr>
-              <a:t>the tool is the reader's job; the form enum inside it is the geometry. Seventeen flat forms is past what a local model picks reliably — seven tools with enums is not.</a:t>
-            </a:r>
-          </a:p>
-        </p:txBody>
-      </p:sp>
-      <p:sp>
-        <p:nvSpPr>
-          <p:cNvPr id="26" name="Rectangle 25"/>
-          <p:cNvSpPr/>
-          <p:nvPr/>
-        </p:nvSpPr>
-        <p:spPr>
-          <a:xfrm>
-            <a:off x="7955279" y="3840480"/>
-            <a:ext cx="3547872" cy="2194560"/>
-          </a:xfrm>
-          <a:prstGeom prst="rect">
-            <a:avLst/>
-          </a:prstGeom>
-          <a:solidFill>
-            <a:srgbClr val="EEF4F8"/>
-          </a:solidFill>
-          <a:ln>
-            <a:noFill/>
-          </a:ln>
-          <a:effectLst/>
-        </p:spPr>
-        <p:style>
-          <a:lnRef idx="1">
-            <a:schemeClr val="accent1"/>
-          </a:lnRef>
-          <a:fillRef idx="3">
-            <a:schemeClr val="accent1"/>
-          </a:fillRef>
-          <a:effectRef idx="2">
-            <a:schemeClr val="accent1"/>
-          </a:effectRef>
-          <a:fontRef idx="minor">
-            <a:schemeClr val="lt1"/>
-          </a:fontRef>
-        </p:style>
-        <p:txBody>
-          <a:bodyPr rtlCol="0" anchor="ctr"/>
-          <a:lstStyle/>
-          <a:p>
-            <a:pPr algn="ctr"/>
-          </a:p>
-        </p:txBody>
-      </p:sp>
-      <p:sp>
-        <p:nvSpPr>
-          <p:cNvPr id="27" name="Rectangle 26"/>
-          <p:cNvSpPr/>
-          <p:nvPr/>
-        </p:nvSpPr>
-        <p:spPr>
-          <a:xfrm>
-            <a:off x="7955279" y="3840480"/>
-            <a:ext cx="3547872" cy="50800"/>
-          </a:xfrm>
-          <a:prstGeom prst="rect">
-            <a:avLst/>
-          </a:prstGeom>
-          <a:solidFill>
-            <a:srgbClr val="B45409"/>
-          </a:solidFill>
-          <a:ln>
-            <a:noFill/>
-          </a:ln>
-          <a:effectLst/>
-        </p:spPr>
-        <p:style>
-          <a:lnRef idx="1">
-            <a:schemeClr val="accent1"/>
-          </a:lnRef>
-          <a:fillRef idx="3">
-            <a:schemeClr val="accent1"/>
-          </a:fillRef>
-          <a:effectRef idx="2">
-            <a:schemeClr val="accent1"/>
-          </a:effectRef>
-          <a:fontRef idx="minor">
-            <a:schemeClr val="lt1"/>
-          </a:fontRef>
-        </p:style>
-        <p:txBody>
-          <a:bodyPr rtlCol="0" anchor="ctr"/>
-          <a:lstStyle/>
-          <a:p>
-            <a:pPr algn="ctr"/>
-          </a:p>
-        </p:txBody>
-      </p:sp>
-      <p:sp>
-        <p:nvSpPr>
-          <p:cNvPr id="28" name="TextBox 27"/>
-          <p:cNvSpPr txBox="1"/>
-          <p:nvPr/>
-        </p:nvSpPr>
-        <p:spPr>
-          <a:xfrm>
-            <a:off x="8202168" y="4041648"/>
-            <a:ext cx="3063240" cy="1828800"/>
-          </a:xfrm>
-          <a:prstGeom prst="rect">
-            <a:avLst/>
-          </a:prstGeom>
-          <a:noFill/>
-        </p:spPr>
-        <p:txBody>
-          <a:bodyPr wrap="square" anchor="t" lIns="0" rIns="0" tIns="0" bIns="0">
-            <a:spAutoFit/>
-          </a:bodyPr>
-          <a:lstStyle/>
-          <a:p>
-            <a:pPr algn="l">
-              <a:lnSpc>
-                <a:spcPct val="114000"/>
-              </a:lnSpc>
-            </a:pPr>
-            <a:r>
-              <a:rPr sz="1250" b="1">
-                <a:solidFill>
-                  <a:srgbClr val="B45409"/>
-                </a:solidFill>
-                <a:latin typeface="Calibri"/>
-              </a:rPr>
-              <a:t>Specified, not wired</a:t>
-            </a:r>
-          </a:p>
-          <a:p>
-            <a:pPr algn="l">
-              <a:lnSpc>
-                <a:spcPct val="114000"/>
-              </a:lnSpc>
-              <a:spcBef>
-                <a:spcPts val="500"/>
-              </a:spcBef>
-            </a:pPr>
-            <a:r>
-              <a:rPr sz="1100" b="0">
-                <a:solidFill>
-                  <a:srgbClr val="0F172A"/>
-                </a:solidFill>
-                <a:latin typeface="Calibri"/>
-              </a:rPr>
-              <a:t>The contract defines these tools and the build emits a JSON schema shaped to drop straight in as an MCP inputSchema — the same file the validator reads, so tool docs and rules cannot drift apart.</a:t>
-            </a:r>
-          </a:p>
-          <a:p>
-            <a:pPr algn="l">
-              <a:lnSpc>
-                <a:spcPct val="114000"/>
-              </a:lnSpc>
-              <a:spcBef>
-                <a:spcPts val="500"/>
-              </a:spcBef>
-            </a:pPr>
-            <a:r>
-              <a:rPr sz="1100" b="1">
-                <a:solidFill>
-                  <a:srgbClr val="0D1B5C"/>
-                </a:solidFill>
-                <a:latin typeface="Calibri"/>
-              </a:rPr>
-              <a:t>Today the selector makes one structured call instead. The surface is a written design, not a running server.</a:t>
-            </a:r>
-          </a:p>
-        </p:txBody>
-      </p:sp>
-      <p:sp>
-        <p:nvSpPr>
-          <p:cNvPr id="29" name="TextBox 28"/>
-          <p:cNvSpPr txBox="1"/>
-          <p:nvPr/>
-        </p:nvSpPr>
-        <p:spPr>
-          <a:xfrm>
-            <a:off x="685800" y="6355080"/>
-            <a:ext cx="8686800" cy="274320"/>
-          </a:xfrm>
-          <a:prstGeom prst="rect">
-            <a:avLst/>
-          </a:prstGeom>
-          <a:noFill/>
-        </p:spPr>
-        <p:txBody>
-          <a:bodyPr wrap="square" anchor="t" lIns="0" rIns="0" tIns="0" bIns="0">
-            <a:spAutoFit/>
-          </a:bodyPr>
-          <a:lstStyle/>
-          <a:p>
-            <a:pPr algn="l">
-              <a:lnSpc>
-                <a:spcPct val="100000"/>
-              </a:lnSpc>
-            </a:pPr>
-            <a:r>
-              <a:rPr sz="900" b="0">
-                <a:solidFill>
-                  <a:srgbClr val="526173"/>
-                </a:solidFill>
-                <a:latin typeface="Calibri"/>
-              </a:rPr>
               <a:t>AI-Powered Data Storytelling  ·  CMS Team Project  ·  TU Dresden  ·  SoSe 2026</a:t>
             </a:r>
           </a:p>
@@ -10603,7 +10847,7 @@
       </p:sp>
       <p:sp>
         <p:nvSpPr>
-          <p:cNvPr id="30" name="TextBox 29"/>
+          <p:cNvPr id="37" name="TextBox 36"/>
           <p:cNvSpPr txBox="1"/>
           <p:nvPr/>
         </p:nvSpPr>

</xml_diff>

<commit_message>
fix(presentation): tighter closing slide, and each number says what it is
The claim ran to three lines of 26pt and buried its own verbs. It is two lines
of 34 now - reaches the human tone level, keeps the numbers, costs some
readability - with one line under it saying all three are measured rather than
asserted. Three verbs, three cards, one number each.

The card captions were doing too little. Each now names its sample: 32 runs
behind the tone move, three blind passes behind the ICC, twenty blind pairs
behind the cost. A number with no n beside it invites the question during Q&A
rather than answering it on the slide.

Limits compressed to one sentence that leads with what is not claimed.
</commit_message>
<xml_diff>
--- a/presentation/AI-Storytelling-Final-Talk.pptx
+++ b/presentation/AI-Storytelling-Final-Talk.pptx
@@ -12534,8 +12534,8 @@
         </p:nvSpPr>
         <p:spPr>
           <a:xfrm>
-            <a:off x="1005840" y="1051560"/>
-            <a:ext cx="10241280" cy="2194560"/>
+            <a:off x="1005840" y="1234440"/>
+            <a:ext cx="10241280" cy="1828800"/>
           </a:xfrm>
           <a:prstGeom prst="rect">
             <a:avLst/>
@@ -12550,7 +12550,7 @@
           <a:p>
             <a:pPr algn="l">
               <a:lnSpc>
-                <a:spcPct val="120000"/>
+                <a:spcPct val="114000"/>
               </a:lnSpc>
             </a:pPr>
             <a:r>
@@ -12566,39 +12566,58 @@
           <a:p>
             <a:pPr algn="l">
               <a:lnSpc>
-                <a:spcPct val="120000"/>
+                <a:spcPct val="114000"/>
               </a:lnSpc>
               <a:spcBef>
-                <a:spcPts val="1000"/>
+                <a:spcPts val="1200"/>
               </a:spcBef>
             </a:pPr>
             <a:r>
-              <a:rPr sz="2600" b="1">
+              <a:rPr sz="3400" b="1">
                 <a:solidFill>
                   <a:srgbClr val="0D1B5C"/>
                 </a:solidFill>
                 <a:latin typeface="Arial"/>
               </a:rPr>
-              <a:t>A second agent can move a generated data story onto the tone level of a person writing from the same table —</a:t>
-            </a:r>
-          </a:p>
-          <a:p>
-            <a:pPr algn="l">
-              <a:lnSpc>
-                <a:spcPct val="120000"/>
+              <a:t>A second agent reaches the human tone level,</a:t>
+            </a:r>
+          </a:p>
+          <a:p>
+            <a:pPr algn="l">
+              <a:lnSpc>
+                <a:spcPct val="114000"/>
               </a:lnSpc>
               <a:spcBef>
                 <a:spcPts val="200"/>
               </a:spcBef>
             </a:pPr>
             <a:r>
-              <a:rPr sz="2600" b="1">
+              <a:rPr sz="3400" b="1">
                 <a:solidFill>
                   <a:srgbClr val="0D1B5C"/>
                 </a:solidFill>
                 <a:latin typeface="Arial"/>
               </a:rPr>
-              <a:t>without losing the numbers, and at a cost in readability we can state.</a:t>
+              <a:t>keeps the numbers, and costs some readability.</a:t>
+            </a:r>
+          </a:p>
+          <a:p>
+            <a:pPr algn="l">
+              <a:lnSpc>
+                <a:spcPct val="114000"/>
+              </a:lnSpc>
+              <a:spcBef>
+                <a:spcPts val="1200"/>
+              </a:spcBef>
+            </a:pPr>
+            <a:r>
+              <a:rPr sz="1500" b="0">
+                <a:solidFill>
+                  <a:srgbClr val="526173"/>
+                </a:solidFill>
+                <a:latin typeface="Calibri"/>
+              </a:rPr>
+              <a:t>All three are measured, not asserted — one number each.</a:t>
             </a:r>
           </a:p>
         </p:txBody>
@@ -12803,7 +12822,7 @@
                 </a:solidFill>
                 <a:latin typeface="Calibri"/>
               </a:rPr>
-              <a:t>alarmism, against a human median of 2.00</a:t>
+              <a:t>alarmism, raw to moderated, over 32 runs. Human median 2.00.</a:t>
             </a:r>
           </a:p>
         </p:txBody>
@@ -13008,7 +13027,7 @@
                 </a:solidFill>
                 <a:latin typeface="Calibri"/>
               </a:rPr>
-              <a:t>ICC, so every number above has an error bar</a:t>
+              <a:t>ICC over 3 blind passes: the judge agrees with itself, so the move above is real.</a:t>
             </a:r>
           </a:p>
         </p:txBody>
@@ -13213,7 +13232,7 @@
                 </a:solidFill>
                 <a:latin typeface="Calibri"/>
               </a:rPr>
-              <a:t>pairs where the raw story still read better</a:t>
+              <a:t>blind pairs where the unmoderated story read better as writing.</a:t>
             </a:r>
           </a:p>
         </p:txBody>
@@ -13246,13 +13265,13 @@
               </a:lnSpc>
             </a:pPr>
             <a:r>
-              <a:rPr sz="1200" b="0">
+              <a:rPr sz="1250" b="0">
                 <a:solidFill>
                   <a:srgbClr val="526173"/>
                 </a:solidFill>
                 <a:latin typeface="Calibri"/>
               </a:rPr>
-              <a:t>What we are not claiming: one judge family agreeing with itself, not a panel. No user study. Twenty-five human stories from five writer slots, not a controlled writer design.</a:t>
+              <a:t>Not claimed: a judge panel, a user study, or a controlled writer design. One judge family, 25 stories, five writer slots.</a:t>
             </a:r>
           </a:p>
           <a:p>
@@ -13261,17 +13280,17 @@
                 <a:spcPct val="116000"/>
               </a:lnSpc>
               <a:spcBef>
-                <a:spcPts val="600"/>
+                <a:spcPts val="700"/>
               </a:spcBef>
             </a:pPr>
             <a:r>
-              <a:rPr sz="1200" b="0">
+              <a:rPr sz="1250" b="0">
                 <a:solidFill>
                   <a:srgbClr val="526173"/>
                 </a:solidFill>
                 <a:latin typeface="Calibri"/>
               </a:rPr>
-              <a:t>Everything in this deck is generated from the experiment files in the repository, so the numbers and the slides cannot drift apart.</a:t>
+              <a:t>Every number here is read from the experiment files at build time, so the slides cannot drift from the data.</a:t>
             </a:r>
           </a:p>
         </p:txBody>

</xml_diff>

<commit_message>
fix(presentation): two titles were carrying arguments, not naming slides
Slide 17's title was a whole two-sentence argument set at 30pt, so it wrapped
and read as a paragraph in title position. The title now names the design -
seven tools, not seventeen chart types - and the reasoning drops to the
subtitle, where a subordinate clause belongs.

Slide 19's claim ran to two lines of 34pt and repeated what the three cards
underneath already say one number at a time. It is one line now, "Human tone
level - and what it cost", with a single line introducing the cards: where the
tone lands, whether the ruler holds, what the rewrite gave up. Each clause
points at one card instead of competing with it.

Both verified as single lines at their point size rather than assumed.
</commit_message>
<xml_diff>
--- a/presentation/AI-Storytelling-Final-Talk.pptx
+++ b/presentation/AI-Storytelling-Final-Talk.pptx
@@ -9446,7 +9446,7 @@
                 </a:solidFill>
                 <a:latin typeface="Arial"/>
               </a:rPr>
-              <a:t>Seventeen flat chart types is past what a local model picks. Seven tools plus an enum is not.</a:t>
+              <a:t>Seven tools, not seventeen chart types</a:t>
             </a:r>
           </a:p>
         </p:txBody>
@@ -9503,8 +9503,8 @@
         </p:nvSpPr>
         <p:spPr>
           <a:xfrm>
-            <a:off x="685800" y="2395728"/>
-            <a:ext cx="5760720" cy="274320"/>
+            <a:off x="685800" y="1874519"/>
+            <a:ext cx="10058400" cy="457200"/>
           </a:xfrm>
           <a:prstGeom prst="rect">
             <a:avLst/>
@@ -9523,6 +9523,45 @@
               </a:lnSpc>
             </a:pPr>
             <a:r>
+              <a:rPr sz="1500" b="0">
+                <a:solidFill>
+                  <a:srgbClr val="526173"/>
+                </a:solidFill>
+                <a:latin typeface="Calibri"/>
+              </a:rPr>
+              <a:t>Grouped by the reader's job, with the geometry in an enum — a two-level choice a local model can make reliably.</a:t>
+            </a:r>
+          </a:p>
+        </p:txBody>
+      </p:sp>
+      <p:sp>
+        <p:nvSpPr>
+          <p:cNvPr id="6" name="TextBox 5"/>
+          <p:cNvSpPr txBox="1"/>
+          <p:nvPr/>
+        </p:nvSpPr>
+        <p:spPr>
+          <a:xfrm>
+            <a:off x="685800" y="2395728"/>
+            <a:ext cx="5760720" cy="274320"/>
+          </a:xfrm>
+          <a:prstGeom prst="rect">
+            <a:avLst/>
+          </a:prstGeom>
+          <a:noFill/>
+        </p:spPr>
+        <p:txBody>
+          <a:bodyPr wrap="square" anchor="t" lIns="0" rIns="0" tIns="0" bIns="0">
+            <a:spAutoFit/>
+          </a:bodyPr>
+          <a:lstStyle/>
+          <a:p>
+            <a:pPr algn="l">
+              <a:lnSpc>
+                <a:spcPct val="100000"/>
+              </a:lnSpc>
+            </a:pPr>
+            <a:r>
               <a:rPr sz="1000" b="1">
                 <a:solidFill>
                   <a:srgbClr val="526173"/>
@@ -9536,7 +9575,7 @@
       </p:sp>
       <p:sp>
         <p:nvSpPr>
-          <p:cNvPr id="6" name="Rectangle 5"/>
+          <p:cNvPr id="7" name="Rectangle 6"/>
           <p:cNvSpPr/>
           <p:nvPr/>
         </p:nvSpPr>
@@ -9580,7 +9619,7 @@
       </p:sp>
       <p:sp>
         <p:nvSpPr>
-          <p:cNvPr id="7" name="TextBox 6"/>
+          <p:cNvPr id="8" name="TextBox 7"/>
           <p:cNvSpPr txBox="1"/>
           <p:nvPr/>
         </p:nvSpPr>
@@ -9619,7 +9658,7 @@
       </p:sp>
       <p:sp>
         <p:nvSpPr>
-          <p:cNvPr id="8" name="TextBox 7"/>
+          <p:cNvPr id="9" name="TextBox 8"/>
           <p:cNvSpPr txBox="1"/>
           <p:nvPr/>
         </p:nvSpPr>
@@ -9658,7 +9697,7 @@
       </p:sp>
       <p:sp>
         <p:nvSpPr>
-          <p:cNvPr id="9" name="TextBox 8"/>
+          <p:cNvPr id="10" name="TextBox 9"/>
           <p:cNvSpPr txBox="1"/>
           <p:nvPr/>
         </p:nvSpPr>
@@ -9697,7 +9736,7 @@
       </p:sp>
       <p:sp>
         <p:nvSpPr>
-          <p:cNvPr id="10" name="TextBox 9"/>
+          <p:cNvPr id="11" name="TextBox 10"/>
           <p:cNvSpPr txBox="1"/>
           <p:nvPr/>
         </p:nvSpPr>
@@ -9736,7 +9775,7 @@
       </p:sp>
       <p:sp>
         <p:nvSpPr>
-          <p:cNvPr id="11" name="Rectangle 10"/>
+          <p:cNvPr id="12" name="Rectangle 11"/>
           <p:cNvSpPr/>
           <p:nvPr/>
         </p:nvSpPr>
@@ -9780,7 +9819,7 @@
       </p:sp>
       <p:sp>
         <p:nvSpPr>
-          <p:cNvPr id="12" name="TextBox 11"/>
+          <p:cNvPr id="13" name="TextBox 12"/>
           <p:cNvSpPr txBox="1"/>
           <p:nvPr/>
         </p:nvSpPr>
@@ -9819,7 +9858,7 @@
       </p:sp>
       <p:sp>
         <p:nvSpPr>
-          <p:cNvPr id="13" name="TextBox 12"/>
+          <p:cNvPr id="14" name="TextBox 13"/>
           <p:cNvSpPr txBox="1"/>
           <p:nvPr/>
         </p:nvSpPr>
@@ -9858,7 +9897,7 @@
       </p:sp>
       <p:sp>
         <p:nvSpPr>
-          <p:cNvPr id="14" name="TextBox 13"/>
+          <p:cNvPr id="15" name="TextBox 14"/>
           <p:cNvSpPr txBox="1"/>
           <p:nvPr/>
         </p:nvSpPr>
@@ -9897,7 +9936,7 @@
       </p:sp>
       <p:sp>
         <p:nvSpPr>
-          <p:cNvPr id="15" name="TextBox 14"/>
+          <p:cNvPr id="16" name="TextBox 15"/>
           <p:cNvSpPr txBox="1"/>
           <p:nvPr/>
         </p:nvSpPr>
@@ -9936,7 +9975,7 @@
       </p:sp>
       <p:sp>
         <p:nvSpPr>
-          <p:cNvPr id="16" name="Rectangle 15"/>
+          <p:cNvPr id="17" name="Rectangle 16"/>
           <p:cNvSpPr/>
           <p:nvPr/>
         </p:nvSpPr>
@@ -9980,7 +10019,7 @@
       </p:sp>
       <p:sp>
         <p:nvSpPr>
-          <p:cNvPr id="17" name="TextBox 16"/>
+          <p:cNvPr id="18" name="TextBox 17"/>
           <p:cNvSpPr txBox="1"/>
           <p:nvPr/>
         </p:nvSpPr>
@@ -10019,7 +10058,7 @@
       </p:sp>
       <p:sp>
         <p:nvSpPr>
-          <p:cNvPr id="18" name="TextBox 17"/>
+          <p:cNvPr id="19" name="TextBox 18"/>
           <p:cNvSpPr txBox="1"/>
           <p:nvPr/>
         </p:nvSpPr>
@@ -10058,7 +10097,7 @@
       </p:sp>
       <p:sp>
         <p:nvSpPr>
-          <p:cNvPr id="19" name="TextBox 18"/>
+          <p:cNvPr id="20" name="TextBox 19"/>
           <p:cNvSpPr txBox="1"/>
           <p:nvPr/>
         </p:nvSpPr>
@@ -10097,7 +10136,7 @@
       </p:sp>
       <p:sp>
         <p:nvSpPr>
-          <p:cNvPr id="20" name="TextBox 19"/>
+          <p:cNvPr id="21" name="TextBox 20"/>
           <p:cNvSpPr txBox="1"/>
           <p:nvPr/>
         </p:nvSpPr>
@@ -10136,7 +10175,7 @@
       </p:sp>
       <p:sp>
         <p:nvSpPr>
-          <p:cNvPr id="21" name="Rectangle 20"/>
+          <p:cNvPr id="22" name="Rectangle 21"/>
           <p:cNvSpPr/>
           <p:nvPr/>
         </p:nvSpPr>
@@ -10180,7 +10219,7 @@
       </p:sp>
       <p:sp>
         <p:nvSpPr>
-          <p:cNvPr id="22" name="TextBox 21"/>
+          <p:cNvPr id="23" name="TextBox 22"/>
           <p:cNvSpPr txBox="1"/>
           <p:nvPr/>
         </p:nvSpPr>
@@ -10219,7 +10258,7 @@
       </p:sp>
       <p:sp>
         <p:nvSpPr>
-          <p:cNvPr id="23" name="TextBox 22"/>
+          <p:cNvPr id="24" name="TextBox 23"/>
           <p:cNvSpPr txBox="1"/>
           <p:nvPr/>
         </p:nvSpPr>
@@ -10258,7 +10297,7 @@
       </p:sp>
       <p:sp>
         <p:nvSpPr>
-          <p:cNvPr id="24" name="TextBox 23"/>
+          <p:cNvPr id="25" name="TextBox 24"/>
           <p:cNvSpPr txBox="1"/>
           <p:nvPr/>
         </p:nvSpPr>
@@ -10297,7 +10336,7 @@
       </p:sp>
       <p:sp>
         <p:nvSpPr>
-          <p:cNvPr id="25" name="TextBox 24"/>
+          <p:cNvPr id="26" name="TextBox 25"/>
           <p:cNvSpPr txBox="1"/>
           <p:nvPr/>
         </p:nvSpPr>
@@ -10336,7 +10375,7 @@
       </p:sp>
       <p:sp>
         <p:nvSpPr>
-          <p:cNvPr id="26" name="Rectangle 25"/>
+          <p:cNvPr id="27" name="Rectangle 26"/>
           <p:cNvSpPr/>
           <p:nvPr/>
         </p:nvSpPr>
@@ -10380,7 +10419,7 @@
       </p:sp>
       <p:sp>
         <p:nvSpPr>
-          <p:cNvPr id="27" name="TextBox 26"/>
+          <p:cNvPr id="28" name="TextBox 27"/>
           <p:cNvSpPr txBox="1"/>
           <p:nvPr/>
         </p:nvSpPr>
@@ -10438,7 +10477,7 @@
       </p:sp>
       <p:sp>
         <p:nvSpPr>
-          <p:cNvPr id="28" name="Rectangle 27"/>
+          <p:cNvPr id="29" name="Rectangle 28"/>
           <p:cNvSpPr/>
           <p:nvPr/>
         </p:nvSpPr>
@@ -10482,7 +10521,7 @@
       </p:sp>
       <p:sp>
         <p:nvSpPr>
-          <p:cNvPr id="29" name="TextBox 28"/>
+          <p:cNvPr id="30" name="TextBox 29"/>
           <p:cNvSpPr txBox="1"/>
           <p:nvPr/>
         </p:nvSpPr>
@@ -10540,7 +10579,7 @@
       </p:sp>
       <p:sp>
         <p:nvSpPr>
-          <p:cNvPr id="30" name="Rectangle 29"/>
+          <p:cNvPr id="31" name="Rectangle 30"/>
           <p:cNvSpPr/>
           <p:nvPr/>
         </p:nvSpPr>
@@ -10584,7 +10623,7 @@
       </p:sp>
       <p:sp>
         <p:nvSpPr>
-          <p:cNvPr id="31" name="TextBox 30"/>
+          <p:cNvPr id="32" name="TextBox 31"/>
           <p:cNvSpPr txBox="1"/>
           <p:nvPr/>
         </p:nvSpPr>
@@ -10642,7 +10681,7 @@
       </p:sp>
       <p:sp>
         <p:nvSpPr>
-          <p:cNvPr id="32" name="Rectangle 31"/>
+          <p:cNvPr id="33" name="Rectangle 32"/>
           <p:cNvSpPr/>
           <p:nvPr/>
         </p:nvSpPr>
@@ -10686,7 +10725,7 @@
       </p:sp>
       <p:sp>
         <p:nvSpPr>
-          <p:cNvPr id="33" name="Rectangle 32"/>
+          <p:cNvPr id="34" name="Rectangle 33"/>
           <p:cNvSpPr/>
           <p:nvPr/>
         </p:nvSpPr>
@@ -10730,7 +10769,7 @@
       </p:sp>
       <p:sp>
         <p:nvSpPr>
-          <p:cNvPr id="34" name="TextBox 33"/>
+          <p:cNvPr id="35" name="TextBox 34"/>
           <p:cNvSpPr txBox="1"/>
           <p:nvPr/>
         </p:nvSpPr>
@@ -10769,7 +10808,7 @@
       </p:sp>
       <p:sp>
         <p:nvSpPr>
-          <p:cNvPr id="35" name="TextBox 34"/>
+          <p:cNvPr id="36" name="TextBox 35"/>
           <p:cNvSpPr txBox="1"/>
           <p:nvPr/>
         </p:nvSpPr>
@@ -10808,7 +10847,7 @@
       </p:sp>
       <p:sp>
         <p:nvSpPr>
-          <p:cNvPr id="36" name="TextBox 35"/>
+          <p:cNvPr id="37" name="TextBox 36"/>
           <p:cNvSpPr txBox="1"/>
           <p:nvPr/>
         </p:nvSpPr>
@@ -10847,7 +10886,7 @@
       </p:sp>
       <p:sp>
         <p:nvSpPr>
-          <p:cNvPr id="37" name="TextBox 36"/>
+          <p:cNvPr id="38" name="TextBox 37"/>
           <p:cNvSpPr txBox="1"/>
           <p:nvPr/>
         </p:nvSpPr>
@@ -12534,8 +12573,8 @@
         </p:nvSpPr>
         <p:spPr>
           <a:xfrm>
-            <a:off x="1005840" y="1234440"/>
-            <a:ext cx="10241280" cy="1828800"/>
+            <a:off x="1005840" y="1371600"/>
+            <a:ext cx="10241280" cy="1737360"/>
           </a:xfrm>
           <a:prstGeom prst="rect">
             <a:avLst/>
@@ -12573,13 +12612,13 @@
               </a:spcBef>
             </a:pPr>
             <a:r>
-              <a:rPr sz="3400" b="1">
+              <a:rPr sz="4000" b="1">
                 <a:solidFill>
                   <a:srgbClr val="0D1B5C"/>
                 </a:solidFill>
                 <a:latin typeface="Arial"/>
               </a:rPr>
-              <a:t>A second agent reaches the human tone level,</a:t>
+              <a:t>Human tone level — and what it cost</a:t>
             </a:r>
           </a:p>
           <a:p>
@@ -12588,36 +12627,17 @@
                 <a:spcPct val="114000"/>
               </a:lnSpc>
               <a:spcBef>
-                <a:spcPts val="200"/>
+                <a:spcPts val="1400"/>
               </a:spcBef>
             </a:pPr>
             <a:r>
-              <a:rPr sz="3400" b="1">
-                <a:solidFill>
-                  <a:srgbClr val="0D1B5C"/>
-                </a:solidFill>
-                <a:latin typeface="Arial"/>
-              </a:rPr>
-              <a:t>keeps the numbers, and costs some readability.</a:t>
-            </a:r>
-          </a:p>
-          <a:p>
-            <a:pPr algn="l">
-              <a:lnSpc>
-                <a:spcPct val="114000"/>
-              </a:lnSpc>
-              <a:spcBef>
-                <a:spcPts val="1200"/>
-              </a:spcBef>
-            </a:pPr>
-            <a:r>
               <a:rPr sz="1500" b="0">
                 <a:solidFill>
                   <a:srgbClr val="526173"/>
                 </a:solidFill>
                 <a:latin typeface="Calibri"/>
               </a:rPr>
-              <a:t>All three are measured, not asserted — one number each.</a:t>
+              <a:t>Three numbers: where the tone lands, whether the ruler holds, and what the rewrite gave up.</a:t>
             </a:r>
           </a:p>
         </p:txBody>

</xml_diff>